<commit_message>
generar_transcripciones.py: videos de YouTube a documentos indexables (Gemini multimodal por URL); probado con video real del canal SAMECO; instructivo D actualizado con la categoría 'azul' del semáforo
Co-Authored-By: Claude Fable 5 <noreply@anthropic.com>
</commit_message>
<xml_diff>
--- a/curso/slides/Sesion_1_Conceptos_y_Descubrimiento.pptx
+++ b/curso/slides/Sesion_1_Conceptos_y_Descubrimiento.pptx
@@ -1423,7 +1423,7 @@
           <a:p>
             <a:fld id="{5BCAD085-E8A6-8845-BD4E-CB4CCA059FC4}" type="datetimeFigureOut">
               <a:rPr lang="en-US" smtClean="0"/>
-              <a:t>8/12/26</a:t>
+              <a:t>8/14/26</a:t>
             </a:fld>
             <a:endParaRPr lang="en-US"/>
           </a:p>
@@ -1591,7 +1591,7 @@
           <a:p>
             <a:fld id="{5BCAD085-E8A6-8845-BD4E-CB4CCA059FC4}" type="datetimeFigureOut">
               <a:rPr lang="en-US" smtClean="0"/>
-              <a:t>8/12/26</a:t>
+              <a:t>8/14/26</a:t>
             </a:fld>
             <a:endParaRPr lang="en-US"/>
           </a:p>
@@ -1769,7 +1769,7 @@
           <a:p>
             <a:fld id="{5BCAD085-E8A6-8845-BD4E-CB4CCA059FC4}" type="datetimeFigureOut">
               <a:rPr lang="en-US" smtClean="0"/>
-              <a:t>8/12/26</a:t>
+              <a:t>8/14/26</a:t>
             </a:fld>
             <a:endParaRPr lang="en-US"/>
           </a:p>
@@ -1937,7 +1937,7 @@
           <a:p>
             <a:fld id="{5BCAD085-E8A6-8845-BD4E-CB4CCA059FC4}" type="datetimeFigureOut">
               <a:rPr lang="en-US" smtClean="0"/>
-              <a:t>8/12/26</a:t>
+              <a:t>8/14/26</a:t>
             </a:fld>
             <a:endParaRPr lang="en-US"/>
           </a:p>
@@ -2182,7 +2182,7 @@
           <a:p>
             <a:fld id="{5BCAD085-E8A6-8845-BD4E-CB4CCA059FC4}" type="datetimeFigureOut">
               <a:rPr lang="en-US" smtClean="0"/>
-              <a:t>8/12/26</a:t>
+              <a:t>8/14/26</a:t>
             </a:fld>
             <a:endParaRPr lang="en-US"/>
           </a:p>
@@ -2467,7 +2467,7 @@
           <a:p>
             <a:fld id="{5BCAD085-E8A6-8845-BD4E-CB4CCA059FC4}" type="datetimeFigureOut">
               <a:rPr lang="en-US" smtClean="0"/>
-              <a:t>8/12/26</a:t>
+              <a:t>8/14/26</a:t>
             </a:fld>
             <a:endParaRPr lang="en-US"/>
           </a:p>
@@ -2886,7 +2886,7 @@
           <a:p>
             <a:fld id="{5BCAD085-E8A6-8845-BD4E-CB4CCA059FC4}" type="datetimeFigureOut">
               <a:rPr lang="en-US" smtClean="0"/>
-              <a:t>8/12/26</a:t>
+              <a:t>8/14/26</a:t>
             </a:fld>
             <a:endParaRPr lang="en-US"/>
           </a:p>
@@ -3003,7 +3003,7 @@
           <a:p>
             <a:fld id="{5BCAD085-E8A6-8845-BD4E-CB4CCA059FC4}" type="datetimeFigureOut">
               <a:rPr lang="en-US" smtClean="0"/>
-              <a:t>8/12/26</a:t>
+              <a:t>8/14/26</a:t>
             </a:fld>
             <a:endParaRPr lang="en-US"/>
           </a:p>
@@ -3098,7 +3098,7 @@
           <a:p>
             <a:fld id="{5BCAD085-E8A6-8845-BD4E-CB4CCA059FC4}" type="datetimeFigureOut">
               <a:rPr lang="en-US" smtClean="0"/>
-              <a:t>8/12/26</a:t>
+              <a:t>8/14/26</a:t>
             </a:fld>
             <a:endParaRPr lang="en-US"/>
           </a:p>
@@ -3373,7 +3373,7 @@
           <a:p>
             <a:fld id="{5BCAD085-E8A6-8845-BD4E-CB4CCA059FC4}" type="datetimeFigureOut">
               <a:rPr lang="en-US" smtClean="0"/>
-              <a:t>8/12/26</a:t>
+              <a:t>8/14/26</a:t>
             </a:fld>
             <a:endParaRPr lang="en-US"/>
           </a:p>
@@ -3625,7 +3625,7 @@
           <a:p>
             <a:fld id="{5BCAD085-E8A6-8845-BD4E-CB4CCA059FC4}" type="datetimeFigureOut">
               <a:rPr lang="en-US" smtClean="0"/>
-              <a:t>8/12/26</a:t>
+              <a:t>8/14/26</a:t>
             </a:fld>
             <a:endParaRPr lang="en-US"/>
           </a:p>
@@ -3836,7 +3836,7 @@
           <a:p>
             <a:fld id="{5BCAD085-E8A6-8845-BD4E-CB4CCA059FC4}" type="datetimeFigureOut">
               <a:rPr lang="en-US" smtClean="0"/>
-              <a:t>8/12/26</a:t>
+              <a:t>8/14/26</a:t>
             </a:fld>
             <a:endParaRPr lang="en-US"/>
           </a:p>
@@ -4367,7 +4367,7 @@
         <p:spPr>
           <a:xfrm>
             <a:off x="822960" y="2057400"/>
-            <a:ext cx="10515600" cy="1645920"/>
+            <a:ext cx="10515600" cy="769441"/>
           </a:xfrm>
           <a:prstGeom prst="rect">
             <a:avLst/>
@@ -4382,15 +4382,65 @@
           <a:p>
             <a:pPr algn="l"/>
             <a:r>
-              <a:rPr sz="4400" b="1">
+              <a:rPr sz="4400" b="1" dirty="0">
                 <a:solidFill>
                   <a:srgbClr val="FFFFFF"/>
                 </a:solidFill>
                 <a:latin typeface="Arial"/>
               </a:rPr>
-              <a:t>Un asistente que responde
-por SAMECO</a:t>
-            </a:r>
+              <a:t>Un </a:t>
+            </a:r>
+            <a:r>
+              <a:rPr sz="4400" b="1" dirty="0" err="1">
+                <a:solidFill>
+                  <a:srgbClr val="FFFFFF"/>
+                </a:solidFill>
+                <a:latin typeface="Arial"/>
+              </a:rPr>
+              <a:t>asistente</a:t>
+            </a:r>
+            <a:r>
+              <a:rPr sz="4400" b="1" dirty="0">
+                <a:solidFill>
+                  <a:srgbClr val="FFFFFF"/>
+                </a:solidFill>
+                <a:latin typeface="Arial"/>
+              </a:rPr>
+              <a:t> </a:t>
+            </a:r>
+            <a:r>
+              <a:rPr sz="4400" b="1" dirty="0" err="1">
+                <a:solidFill>
+                  <a:srgbClr val="FFFFFF"/>
+                </a:solidFill>
+                <a:latin typeface="Arial"/>
+              </a:rPr>
+              <a:t>que</a:t>
+            </a:r>
+            <a:r>
+              <a:rPr sz="4400" b="1" dirty="0">
+                <a:solidFill>
+                  <a:srgbClr val="FFFFFF"/>
+                </a:solidFill>
+                <a:latin typeface="Arial"/>
+              </a:rPr>
+              <a:t> </a:t>
+            </a:r>
+            <a:r>
+              <a:rPr sz="4400" b="1" dirty="0" err="1">
+                <a:solidFill>
+                  <a:srgbClr val="FFFFFF"/>
+                </a:solidFill>
+                <a:latin typeface="Arial"/>
+              </a:rPr>
+              <a:t>responde</a:t>
+            </a:r>
+            <a:endParaRPr sz="4400" b="1" dirty="0">
+              <a:solidFill>
+                <a:srgbClr val="FFFFFF"/>
+              </a:solidFill>
+              <a:latin typeface="Arial"/>
+            </a:endParaRPr>
           </a:p>
         </p:txBody>
       </p:sp>
@@ -5190,14 +5240,65 @@
           <a:p>
             <a:pPr algn="l"/>
             <a:r>
-              <a:rPr sz="3000" b="1">
+              <a:rPr sz="3000" b="1" dirty="0">
                 <a:solidFill>
                   <a:srgbClr val="1F2937"/>
                 </a:solidFill>
                 <a:latin typeface="Arial"/>
               </a:rPr>
-              <a:t>El diseño: un asistente, dos bibliotecas</a:t>
-            </a:r>
+              <a:t>El </a:t>
+            </a:r>
+            <a:r>
+              <a:rPr sz="3000" b="1" dirty="0" err="1">
+                <a:solidFill>
+                  <a:srgbClr val="1F2937"/>
+                </a:solidFill>
+                <a:latin typeface="Arial"/>
+              </a:rPr>
+              <a:t>diseño</a:t>
+            </a:r>
+            <a:r>
+              <a:rPr sz="3000" b="1" dirty="0">
+                <a:solidFill>
+                  <a:srgbClr val="1F2937"/>
+                </a:solidFill>
+                <a:latin typeface="Arial"/>
+              </a:rPr>
+              <a:t>: un </a:t>
+            </a:r>
+            <a:r>
+              <a:rPr sz="3000" b="1" dirty="0" err="1">
+                <a:solidFill>
+                  <a:srgbClr val="1F2937"/>
+                </a:solidFill>
+                <a:latin typeface="Arial"/>
+              </a:rPr>
+              <a:t>asistente</a:t>
+            </a:r>
+            <a:r>
+              <a:rPr sz="3000" b="1" dirty="0">
+                <a:solidFill>
+                  <a:srgbClr val="1F2937"/>
+                </a:solidFill>
+                <a:latin typeface="Arial"/>
+              </a:rPr>
+              <a:t>, dos </a:t>
+            </a:r>
+            <a:r>
+              <a:rPr sz="3000" b="1" dirty="0" err="1">
+                <a:solidFill>
+                  <a:srgbClr val="1F2937"/>
+                </a:solidFill>
+                <a:latin typeface="Arial"/>
+              </a:rPr>
+              <a:t>bibliotecas</a:t>
+            </a:r>
+            <a:endParaRPr sz="3000" b="1" dirty="0">
+              <a:solidFill>
+                <a:srgbClr val="1F2937"/>
+              </a:solidFill>
+              <a:latin typeface="Arial"/>
+            </a:endParaRPr>
           </a:p>
         </p:txBody>
       </p:sp>

</xml_diff>